<commit_message>
sistemazione scenari prioritari presentazione
</commit_message>
<xml_diff>
--- a/presentazione/Progetto1.2_Presentazione.pptx
+++ b/presentazione/Progetto1.2_Presentazione.pptx
@@ -325,7 +325,7 @@
           <a:p>
             <a:fld id="{5BCAD085-E8A6-8845-BD4E-CB4CCA059FC4}" type="datetimeFigureOut">
               <a:rPr lang="en-US" smtClean="0"/>
-              <a:t>9/17/2026</a:t>
+              <a:t>10/2/2026</a:t>
             </a:fld>
             <a:endParaRPr lang="en-US"/>
           </a:p>
@@ -493,7 +493,7 @@
           <a:p>
             <a:fld id="{5BCAD085-E8A6-8845-BD4E-CB4CCA059FC4}" type="datetimeFigureOut">
               <a:rPr lang="en-US" smtClean="0"/>
-              <a:t>9/17/2026</a:t>
+              <a:t>10/2/2026</a:t>
             </a:fld>
             <a:endParaRPr lang="en-US"/>
           </a:p>
@@ -671,7 +671,7 @@
           <a:p>
             <a:fld id="{5BCAD085-E8A6-8845-BD4E-CB4CCA059FC4}" type="datetimeFigureOut">
               <a:rPr lang="en-US" smtClean="0"/>
-              <a:t>9/17/2026</a:t>
+              <a:t>10/2/2026</a:t>
             </a:fld>
             <a:endParaRPr lang="en-US"/>
           </a:p>
@@ -839,7 +839,7 @@
           <a:p>
             <a:fld id="{5BCAD085-E8A6-8845-BD4E-CB4CCA059FC4}" type="datetimeFigureOut">
               <a:rPr lang="en-US" smtClean="0"/>
-              <a:t>9/17/2026</a:t>
+              <a:t>10/2/2026</a:t>
             </a:fld>
             <a:endParaRPr lang="en-US"/>
           </a:p>
@@ -1084,7 +1084,7 @@
           <a:p>
             <a:fld id="{5BCAD085-E8A6-8845-BD4E-CB4CCA059FC4}" type="datetimeFigureOut">
               <a:rPr lang="en-US" smtClean="0"/>
-              <a:t>9/17/2026</a:t>
+              <a:t>10/2/2026</a:t>
             </a:fld>
             <a:endParaRPr lang="en-US"/>
           </a:p>
@@ -1369,7 +1369,7 @@
           <a:p>
             <a:fld id="{5BCAD085-E8A6-8845-BD4E-CB4CCA059FC4}" type="datetimeFigureOut">
               <a:rPr lang="en-US" smtClean="0"/>
-              <a:t>9/17/2026</a:t>
+              <a:t>10/2/2026</a:t>
             </a:fld>
             <a:endParaRPr lang="en-US"/>
           </a:p>
@@ -1788,7 +1788,7 @@
           <a:p>
             <a:fld id="{5BCAD085-E8A6-8845-BD4E-CB4CCA059FC4}" type="datetimeFigureOut">
               <a:rPr lang="en-US" smtClean="0"/>
-              <a:t>9/17/2026</a:t>
+              <a:t>10/2/2026</a:t>
             </a:fld>
             <a:endParaRPr lang="en-US"/>
           </a:p>
@@ -1905,7 +1905,7 @@
           <a:p>
             <a:fld id="{5BCAD085-E8A6-8845-BD4E-CB4CCA059FC4}" type="datetimeFigureOut">
               <a:rPr lang="en-US" smtClean="0"/>
-              <a:t>9/17/2026</a:t>
+              <a:t>10/2/2026</a:t>
             </a:fld>
             <a:endParaRPr lang="en-US"/>
           </a:p>
@@ -2000,7 +2000,7 @@
           <a:p>
             <a:fld id="{5BCAD085-E8A6-8845-BD4E-CB4CCA059FC4}" type="datetimeFigureOut">
               <a:rPr lang="en-US" smtClean="0"/>
-              <a:t>9/17/2026</a:t>
+              <a:t>10/2/2026</a:t>
             </a:fld>
             <a:endParaRPr lang="en-US"/>
           </a:p>
@@ -2275,7 +2275,7 @@
           <a:p>
             <a:fld id="{5BCAD085-E8A6-8845-BD4E-CB4CCA059FC4}" type="datetimeFigureOut">
               <a:rPr lang="en-US" smtClean="0"/>
-              <a:t>9/17/2026</a:t>
+              <a:t>10/2/2026</a:t>
             </a:fld>
             <a:endParaRPr lang="en-US"/>
           </a:p>
@@ -2527,7 +2527,7 @@
           <a:p>
             <a:fld id="{5BCAD085-E8A6-8845-BD4E-CB4CCA059FC4}" type="datetimeFigureOut">
               <a:rPr lang="en-US" smtClean="0"/>
-              <a:t>9/17/2026</a:t>
+              <a:t>10/2/2026</a:t>
             </a:fld>
             <a:endParaRPr lang="en-US"/>
           </a:p>
@@ -2738,7 +2738,7 @@
           <a:p>
             <a:fld id="{5BCAD085-E8A6-8845-BD4E-CB4CCA059FC4}" type="datetimeFigureOut">
               <a:rPr lang="en-US" smtClean="0"/>
-              <a:t>9/17/2026</a:t>
+              <a:t>10/2/2026</a:t>
             </a:fld>
             <a:endParaRPr lang="en-US"/>
           </a:p>
@@ -10807,7 +10807,7 @@
         <p:spPr>
           <a:xfrm>
             <a:off x="727710" y="1089660"/>
-            <a:ext cx="6606097" cy="548640"/>
+            <a:ext cx="6981783" cy="415498"/>
           </a:xfrm>
           <a:prstGeom prst="rect">
             <a:avLst/>
@@ -10833,7 +10833,7 @@
                 <a:ea typeface="Microsoft YaHei"/>
                 <a:cs typeface="Segoe UI"/>
               </a:rPr>
-              <a:t>Goal Hijack &amp; Chunk Splitting</a:t>
+              <a:t>Goal Hijack del Fast-Brain e del Deep-Brain</a:t>
             </a:r>
           </a:p>
         </p:txBody>
@@ -10973,8 +10973,8 @@
           </p:nvSpPr>
           <p:spPr>
             <a:xfrm>
-              <a:off x="1835456" y="1666399"/>
-              <a:ext cx="805838" cy="198120"/>
+              <a:off x="1997926" y="1666399"/>
+              <a:ext cx="480901" cy="150041"/>
             </a:xfrm>
             <a:prstGeom prst="rect">
               <a:avLst/>
@@ -11000,7 +11000,7 @@
                   <a:ea typeface="Microsoft YaHei"/>
                   <a:cs typeface="Aptos"/>
                 </a:rPr>
-                <a:t>Integrity</a:t>
+                <a:t>Integrità</a:t>
               </a:r>
             </a:p>
           </p:txBody>
@@ -11086,8 +11086,8 @@
           </p:nvSpPr>
           <p:spPr>
             <a:xfrm>
-              <a:off x="2737114" y="1666399"/>
-              <a:ext cx="1288523" cy="198120"/>
+              <a:off x="2963795" y="1666399"/>
+              <a:ext cx="835165" cy="150041"/>
             </a:xfrm>
             <a:prstGeom prst="rect">
               <a:avLst/>
@@ -11105,7 +11105,7 @@
             <a:p>
               <a:pPr algn="ctr"/>
               <a:r>
-                <a:rPr lang="en-US" sz="975" b="1" dirty="0">
+                <a:rPr lang="en-US" sz="975" b="1" dirty="0" err="1">
                   <a:solidFill>
                     <a:srgbClr val="C4362E"/>
                   </a:solidFill>
@@ -11113,8 +11113,16 @@
                   <a:ea typeface="Microsoft YaHei"/>
                   <a:cs typeface="Aptos"/>
                 </a:rPr>
-                <a:t>Authentication</a:t>
-              </a:r>
+                <a:t>Autorizzazione</a:t>
+              </a:r>
+              <a:endParaRPr lang="en-US" sz="975" b="1" dirty="0">
+                <a:solidFill>
+                  <a:srgbClr val="C4362E"/>
+                </a:solidFill>
+                <a:latin typeface="Aptos"/>
+                <a:ea typeface="Microsoft YaHei"/>
+                <a:cs typeface="Aptos"/>
+              </a:endParaRPr>
             </a:p>
           </p:txBody>
         </p:sp>
@@ -11846,9 +11854,9 @@
         <p:grpSpPr>
           <a:xfrm>
             <a:off x="6462712" y="2717006"/>
-            <a:ext cx="4967299" cy="2419350"/>
+            <a:ext cx="4397335" cy="2419350"/>
             <a:chOff x="6462712" y="2717006"/>
-            <a:chExt cx="4967299" cy="2419350"/>
+            <a:chExt cx="4397335" cy="2419350"/>
           </a:xfrm>
         </p:grpSpPr>
         <p:sp>
@@ -11860,7 +11868,7 @@
           <p:spPr>
             <a:xfrm>
               <a:off x="6462712" y="2717006"/>
-              <a:ext cx="4967299" cy="228600"/>
+              <a:ext cx="3298980" cy="173124"/>
             </a:xfrm>
             <a:prstGeom prst="rect">
               <a:avLst/>
@@ -11886,7 +11894,7 @@
                   <a:ea typeface="Microsoft YaHei"/>
                   <a:cs typeface="Aptos"/>
                 </a:rPr>
-                <a:t>P1</a:t>
+                <a:t>P1 </a:t>
               </a:r>
               <a:r>
                 <a:rPr lang="en-US" sz="1125" dirty="0">
@@ -11951,7 +11959,7 @@
           <p:spPr>
             <a:xfrm>
               <a:off x="6462712" y="3364706"/>
-              <a:ext cx="3800368" cy="228600"/>
+              <a:ext cx="2587247" cy="173124"/>
             </a:xfrm>
             <a:prstGeom prst="rect">
               <a:avLst/>
@@ -11977,7 +11985,7 @@
                   <a:ea typeface="Microsoft YaHei"/>
                   <a:cs typeface="Aptos"/>
                 </a:rPr>
-                <a:t>P2</a:t>
+                <a:t>P2 </a:t>
               </a:r>
               <a:r>
                 <a:rPr lang="en-US" sz="1125" dirty="0">
@@ -12042,7 +12050,7 @@
           <p:spPr>
             <a:xfrm>
               <a:off x="6462712" y="4012406"/>
-              <a:ext cx="4031825" cy="228600"/>
+              <a:ext cx="2657779" cy="173124"/>
             </a:xfrm>
             <a:prstGeom prst="rect">
               <a:avLst/>
@@ -12068,7 +12076,7 @@
                   <a:ea typeface="Microsoft YaHei"/>
                   <a:cs typeface="Aptos"/>
                 </a:rPr>
-                <a:t>P3</a:t>
+                <a:t>P3 </a:t>
               </a:r>
               <a:r>
                 <a:rPr lang="en-US" sz="1125" dirty="0">
@@ -12133,7 +12141,7 @@
           <p:spPr>
             <a:xfrm>
               <a:off x="6462712" y="4660106"/>
-              <a:ext cx="4202043" cy="228600"/>
+              <a:ext cx="2867773" cy="173124"/>
             </a:xfrm>
             <a:prstGeom prst="rect">
               <a:avLst/>
@@ -12159,7 +12167,18 @@
                   <a:ea typeface="Microsoft YaHei"/>
                   <a:cs typeface="Aptos"/>
                 </a:rPr>
-                <a:t>P4+P6</a:t>
+                <a:t>P4+P6 </a:t>
+              </a:r>
+              <a:r>
+                <a:rPr lang="en-US" sz="1125" dirty="0" err="1">
+                  <a:solidFill>
+                    <a:srgbClr val="3A4149"/>
+                  </a:solidFill>
+                  <a:latin typeface="Aptos"/>
+                  <a:ea typeface="Microsoft YaHei"/>
+                  <a:cs typeface="Aptos"/>
+                </a:rPr>
+                <a:t>Tracciamento</a:t>
               </a:r>
               <a:r>
                 <a:rPr lang="en-US" sz="1125" dirty="0">
@@ -12170,7 +12189,7 @@
                   <a:ea typeface="Microsoft YaHei"/>
                   <a:cs typeface="Aptos"/>
                 </a:rPr>
-                <a:t>Tracciamento immutabile degli eventi e</a:t>
+                <a:t> immutabile degli eventi e</a:t>
               </a:r>
             </a:p>
           </p:txBody>
@@ -12270,8 +12289,8 @@
         </p:nvSpPr>
         <p:spPr>
           <a:xfrm>
-            <a:off x="725806" y="1008531"/>
-            <a:ext cx="4809755" cy="57600"/>
+            <a:off x="725806" y="1008530"/>
+            <a:ext cx="6894194" cy="57600"/>
           </a:xfrm>
           <a:prstGeom prst="rect">
             <a:avLst/>
@@ -12563,8 +12582,8 @@
           </p:nvSpPr>
           <p:spPr>
             <a:xfrm>
-              <a:off x="1835456" y="1666399"/>
-              <a:ext cx="805838" cy="198120"/>
+              <a:off x="1997926" y="1666399"/>
+              <a:ext cx="480901" cy="150041"/>
             </a:xfrm>
             <a:prstGeom prst="rect">
               <a:avLst/>
@@ -12590,7 +12609,7 @@
                   <a:ea typeface="Microsoft YaHei"/>
                   <a:cs typeface="Aptos"/>
                 </a:rPr>
-                <a:t>Integrity</a:t>
+                <a:t>Integrità</a:t>
               </a:r>
             </a:p>
           </p:txBody>
@@ -12676,8 +12695,8 @@
           </p:nvSpPr>
           <p:spPr>
             <a:xfrm>
-              <a:off x="2685100" y="1666399"/>
-              <a:ext cx="1297299" cy="198120"/>
+              <a:off x="2900139" y="1666399"/>
+              <a:ext cx="867225" cy="150041"/>
             </a:xfrm>
             <a:prstGeom prst="rect">
               <a:avLst/>
@@ -12695,7 +12714,7 @@
             <a:p>
               <a:pPr algn="ctr"/>
               <a:r>
-                <a:rPr lang="en-US" sz="975" b="1" dirty="0">
+                <a:rPr lang="en-US" sz="975" b="1" dirty="0" err="1">
                   <a:solidFill>
                     <a:srgbClr val="C4362E"/>
                   </a:solidFill>
@@ -12703,8 +12722,16 @@
                   <a:ea typeface="Microsoft YaHei"/>
                   <a:cs typeface="Aptos"/>
                 </a:rPr>
-                <a:t>Confidentiality</a:t>
-              </a:r>
+                <a:t>Confidenzialità</a:t>
+              </a:r>
+              <a:endParaRPr lang="en-US" sz="975" b="1" dirty="0">
+                <a:solidFill>
+                  <a:srgbClr val="C4362E"/>
+                </a:solidFill>
+                <a:latin typeface="Aptos"/>
+                <a:ea typeface="Microsoft YaHei"/>
+                <a:cs typeface="Aptos"/>
+              </a:endParaRPr>
             </a:p>
           </p:txBody>
         </p:sp>
@@ -13563,7 +13590,7 @@
           <p:spPr>
             <a:xfrm>
               <a:off x="6462712" y="2717006"/>
-              <a:ext cx="4147554" cy="228600"/>
+              <a:ext cx="2625719" cy="173124"/>
             </a:xfrm>
             <a:prstGeom prst="rect">
               <a:avLst/>
@@ -13589,7 +13616,7 @@
                   <a:ea typeface="Microsoft YaHei"/>
                   <a:cs typeface="Aptos"/>
                 </a:rPr>
-                <a:t>P1</a:t>
+                <a:t>P1 </a:t>
               </a:r>
               <a:r>
                 <a:rPr lang="en-US" sz="1125" dirty="0">
@@ -13654,7 +13681,7 @@
           <p:spPr>
             <a:xfrm>
               <a:off x="6462712" y="3364706"/>
-              <a:ext cx="4157198" cy="228600"/>
+              <a:ext cx="2779607" cy="173124"/>
             </a:xfrm>
             <a:prstGeom prst="rect">
               <a:avLst/>
@@ -13680,7 +13707,7 @@
                   <a:ea typeface="Microsoft YaHei"/>
                   <a:cs typeface="Aptos"/>
                 </a:rPr>
-                <a:t>P2</a:t>
+                <a:t>P2 </a:t>
               </a:r>
               <a:r>
                 <a:rPr lang="en-US" sz="1125" dirty="0">
@@ -13745,7 +13772,7 @@
           <p:spPr>
             <a:xfrm>
               <a:off x="6462712" y="4012406"/>
-              <a:ext cx="3916097" cy="228600"/>
+              <a:ext cx="2632131" cy="173124"/>
             </a:xfrm>
             <a:prstGeom prst="rect">
               <a:avLst/>
@@ -13771,7 +13798,7 @@
                   <a:ea typeface="Microsoft YaHei"/>
                   <a:cs typeface="Aptos"/>
                 </a:rPr>
-                <a:t>P3</a:t>
+                <a:t>P3 </a:t>
               </a:r>
               <a:r>
                 <a:rPr lang="en-US" sz="1125" dirty="0">
@@ -13836,7 +13863,7 @@
           <p:spPr>
             <a:xfrm>
               <a:off x="6462712" y="4660106"/>
-              <a:ext cx="4684246" cy="228600"/>
+              <a:ext cx="3058530" cy="173124"/>
             </a:xfrm>
             <a:prstGeom prst="rect">
               <a:avLst/>
@@ -13862,7 +13889,7 @@
                   <a:ea typeface="Microsoft YaHei"/>
                   <a:cs typeface="Aptos"/>
                 </a:rPr>
-                <a:t>P4+P6</a:t>
+                <a:t>P4+P6 </a:t>
               </a:r>
               <a:r>
                 <a:rPr lang="en-US" sz="1125" dirty="0">
@@ -14031,7 +14058,7 @@
         <p:spPr>
           <a:xfrm>
             <a:off x="0" y="0"/>
-            <a:ext cx="12192000" cy="6858000"/>
+            <a:ext cx="12168000" cy="6858000"/>
           </a:xfrm>
           <a:prstGeom prst="rect">
             <a:avLst/>
@@ -14100,7 +14127,7 @@
         <p:spPr>
           <a:xfrm>
             <a:off x="727710" y="1089660"/>
-            <a:ext cx="6047127" cy="548640"/>
+            <a:ext cx="7187609" cy="415498"/>
           </a:xfrm>
           <a:prstGeom prst="rect">
             <a:avLst/>
@@ -14118,6 +14145,17 @@
           <a:p>
             <a:pPr algn="l"/>
             <a:r>
+              <a:rPr lang="en-US" sz="2700" b="1" dirty="0" err="1">
+                <a:solidFill>
+                  <a:srgbClr val="1A1D23"/>
+                </a:solidFill>
+                <a:latin typeface="Segoe UI"/>
+                <a:ea typeface="Microsoft YaHei"/>
+                <a:cs typeface="Segoe UI"/>
+              </a:rPr>
+              <a:t>Abuso</a:t>
+            </a:r>
+            <a:r>
               <a:rPr lang="en-US" sz="2700" b="1" dirty="0">
                 <a:solidFill>
                   <a:srgbClr val="1A1D23"/>
@@ -14126,8 +14164,93 @@
                 <a:ea typeface="Microsoft YaHei"/>
                 <a:cs typeface="Segoe UI"/>
               </a:rPr>
-              <a:t>Identity &amp; Privilege Abuse</a:t>
+              <a:t> di </a:t>
             </a:r>
+            <a:r>
+              <a:rPr lang="en-US" sz="2700" b="1" dirty="0" err="1">
+                <a:solidFill>
+                  <a:srgbClr val="1A1D23"/>
+                </a:solidFill>
+                <a:latin typeface="Segoe UI"/>
+                <a:ea typeface="Microsoft YaHei"/>
+                <a:cs typeface="Segoe UI"/>
+              </a:rPr>
+              <a:t>Identità</a:t>
+            </a:r>
+            <a:r>
+              <a:rPr lang="en-US" sz="2700" b="1" dirty="0">
+                <a:solidFill>
+                  <a:srgbClr val="1A1D23"/>
+                </a:solidFill>
+                <a:latin typeface="Segoe UI"/>
+                <a:ea typeface="Microsoft YaHei"/>
+                <a:cs typeface="Segoe UI"/>
+              </a:rPr>
+              <a:t> e </a:t>
+            </a:r>
+            <a:r>
+              <a:rPr lang="en-US" sz="2700" b="1" dirty="0" err="1">
+                <a:solidFill>
+                  <a:srgbClr val="1A1D23"/>
+                </a:solidFill>
+                <a:latin typeface="Segoe UI"/>
+                <a:ea typeface="Microsoft YaHei"/>
+                <a:cs typeface="Segoe UI"/>
+              </a:rPr>
+              <a:t>Privilegi</a:t>
+            </a:r>
+            <a:r>
+              <a:rPr lang="en-US" sz="2700" b="1" dirty="0">
+                <a:solidFill>
+                  <a:srgbClr val="1A1D23"/>
+                </a:solidFill>
+                <a:latin typeface="Segoe UI"/>
+                <a:ea typeface="Microsoft YaHei"/>
+                <a:cs typeface="Segoe UI"/>
+              </a:rPr>
+              <a:t> </a:t>
+            </a:r>
+            <a:r>
+              <a:rPr lang="en-US" sz="2700" b="1" dirty="0" err="1">
+                <a:solidFill>
+                  <a:srgbClr val="1A1D23"/>
+                </a:solidFill>
+                <a:latin typeface="Segoe UI"/>
+                <a:ea typeface="Microsoft YaHei"/>
+                <a:cs typeface="Segoe UI"/>
+              </a:rPr>
+              <a:t>tra</a:t>
+            </a:r>
+            <a:r>
+              <a:rPr lang="en-US" sz="2700" b="1" dirty="0">
+                <a:solidFill>
+                  <a:srgbClr val="1A1D23"/>
+                </a:solidFill>
+                <a:latin typeface="Segoe UI"/>
+                <a:ea typeface="Microsoft YaHei"/>
+                <a:cs typeface="Segoe UI"/>
+              </a:rPr>
+              <a:t> </a:t>
+            </a:r>
+            <a:r>
+              <a:rPr lang="en-US" sz="2700" b="1" dirty="0" err="1">
+                <a:solidFill>
+                  <a:srgbClr val="1A1D23"/>
+                </a:solidFill>
+                <a:latin typeface="Segoe UI"/>
+                <a:ea typeface="Microsoft YaHei"/>
+                <a:cs typeface="Segoe UI"/>
+              </a:rPr>
+              <a:t>Componenti</a:t>
+            </a:r>
+            <a:endParaRPr lang="en-US" sz="2700" b="1" dirty="0">
+              <a:solidFill>
+                <a:srgbClr val="1A1D23"/>
+              </a:solidFill>
+              <a:latin typeface="Segoe UI"/>
+              <a:ea typeface="Microsoft YaHei"/>
+              <a:cs typeface="Segoe UI"/>
+            </a:endParaRPr>
           </a:p>
         </p:txBody>
       </p:sp>
@@ -14179,10 +14302,10 @@
         </p:nvGrpSpPr>
         <p:grpSpPr>
           <a:xfrm>
-            <a:off x="1784614" y="1600200"/>
-            <a:ext cx="5048007" cy="264319"/>
-            <a:chOff x="1784614" y="1600200"/>
-            <a:chExt cx="5048007" cy="264319"/>
+            <a:off x="1809750" y="1600200"/>
+            <a:ext cx="5022871" cy="264319"/>
+            <a:chOff x="1809750" y="1600200"/>
+            <a:chExt cx="5022871" cy="264319"/>
           </a:xfrm>
         </p:grpSpPr>
         <p:sp>
@@ -14266,8 +14389,8 @@
           </p:nvSpPr>
           <p:spPr>
             <a:xfrm>
-              <a:off x="1784614" y="1666399"/>
-              <a:ext cx="1288523" cy="198120"/>
+              <a:off x="2000875" y="1666399"/>
+              <a:ext cx="856005" cy="150041"/>
             </a:xfrm>
             <a:prstGeom prst="rect">
               <a:avLst/>
@@ -14285,7 +14408,7 @@
             <a:p>
               <a:pPr algn="ctr"/>
               <a:r>
-                <a:rPr lang="en-US" sz="975" b="1" dirty="0">
+                <a:rPr lang="en-US" sz="975" b="1" dirty="0" err="1">
                   <a:solidFill>
                     <a:srgbClr val="B87710"/>
                   </a:solidFill>
@@ -14293,8 +14416,16 @@
                   <a:ea typeface="Microsoft YaHei"/>
                   <a:cs typeface="Aptos"/>
                 </a:rPr>
-                <a:t>Authentication</a:t>
-              </a:r>
+                <a:t>Autenticazione</a:t>
+              </a:r>
+              <a:endParaRPr lang="en-US" sz="975" b="1" dirty="0">
+                <a:solidFill>
+                  <a:srgbClr val="B87710"/>
+                </a:solidFill>
+                <a:latin typeface="Aptos"/>
+                <a:ea typeface="Microsoft YaHei"/>
+                <a:cs typeface="Aptos"/>
+              </a:endParaRPr>
             </a:p>
           </p:txBody>
         </p:sp>
@@ -14379,8 +14510,8 @@
           </p:nvSpPr>
           <p:spPr>
             <a:xfrm>
-              <a:off x="3118757" y="1666399"/>
-              <a:ext cx="1191986" cy="198120"/>
+              <a:off x="3297170" y="1666399"/>
+              <a:ext cx="835165" cy="150041"/>
             </a:xfrm>
             <a:prstGeom prst="rect">
               <a:avLst/>
@@ -14398,7 +14529,7 @@
             <a:p>
               <a:pPr algn="ctr"/>
               <a:r>
-                <a:rPr lang="en-US" sz="975" b="1" dirty="0">
+                <a:rPr lang="en-US" sz="975" b="1" dirty="0" err="1">
                   <a:solidFill>
                     <a:srgbClr val="B87710"/>
                   </a:solidFill>
@@ -14406,8 +14537,16 @@
                   <a:ea typeface="Microsoft YaHei"/>
                   <a:cs typeface="Aptos"/>
                 </a:rPr>
-                <a:t>Authorization</a:t>
-              </a:r>
+                <a:t>Autorizzazione</a:t>
+              </a:r>
+              <a:endParaRPr lang="en-US" sz="975" b="1" dirty="0">
+                <a:solidFill>
+                  <a:srgbClr val="B87710"/>
+                </a:solidFill>
+                <a:latin typeface="Aptos"/>
+                <a:ea typeface="Microsoft YaHei"/>
+                <a:cs typeface="Aptos"/>
+              </a:endParaRPr>
             </a:p>
           </p:txBody>
         </p:sp>
@@ -14492,8 +14631,8 @@
           </p:nvSpPr>
           <p:spPr>
             <a:xfrm>
-              <a:off x="4304350" y="1666399"/>
-              <a:ext cx="1297299" cy="198120"/>
+              <a:off x="4519389" y="1666399"/>
+              <a:ext cx="867225" cy="150041"/>
             </a:xfrm>
             <a:prstGeom prst="rect">
               <a:avLst/>
@@ -14511,7 +14650,7 @@
             <a:p>
               <a:pPr algn="ctr"/>
               <a:r>
-                <a:rPr lang="en-US" sz="975" b="1" dirty="0">
+                <a:rPr lang="en-US" sz="975" b="1" dirty="0" err="1">
                   <a:solidFill>
                     <a:srgbClr val="B87710"/>
                   </a:solidFill>
@@ -14519,8 +14658,16 @@
                   <a:ea typeface="Microsoft YaHei"/>
                   <a:cs typeface="Aptos"/>
                 </a:rPr>
-                <a:t>Confidentiality</a:t>
-              </a:r>
+                <a:t>Confidenzialità</a:t>
+              </a:r>
+              <a:endParaRPr lang="en-US" sz="975" b="1" dirty="0">
+                <a:solidFill>
+                  <a:srgbClr val="B87710"/>
+                </a:solidFill>
+                <a:latin typeface="Aptos"/>
+                <a:ea typeface="Microsoft YaHei"/>
+                <a:cs typeface="Aptos"/>
+              </a:endParaRPr>
             </a:p>
           </p:txBody>
         </p:sp>
@@ -15266,7 +15413,7 @@
           <p:spPr>
             <a:xfrm>
               <a:off x="6462712" y="2717006"/>
-              <a:ext cx="4330791" cy="228600"/>
+              <a:ext cx="2835713" cy="173124"/>
             </a:xfrm>
             <a:prstGeom prst="rect">
               <a:avLst/>
@@ -15292,7 +15439,18 @@
                   <a:ea typeface="Microsoft YaHei"/>
                   <a:cs typeface="Aptos"/>
                 </a:rPr>
-                <a:t>P1</a:t>
+                <a:t>P1 </a:t>
+              </a:r>
+              <a:r>
+                <a:rPr lang="en-US" sz="1125" dirty="0" err="1">
+                  <a:solidFill>
+                    <a:srgbClr val="3A4149"/>
+                  </a:solidFill>
+                  <a:latin typeface="Aptos"/>
+                  <a:ea typeface="Microsoft YaHei"/>
+                  <a:cs typeface="Aptos"/>
+                </a:rPr>
+                <a:t>Segregazione</a:t>
               </a:r>
               <a:r>
                 <a:rPr lang="en-US" sz="1125" dirty="0">
@@ -15303,7 +15461,7 @@
                   <a:ea typeface="Microsoft YaHei"/>
                   <a:cs typeface="Aptos"/>
                 </a:rPr>
-                <a:t>Segregazione delle identità tecniche (D13);</a:t>
+                <a:t> delle identità tecniche (D13);</a:t>
               </a:r>
             </a:p>
           </p:txBody>
@@ -15357,7 +15515,7 @@
           <p:spPr>
             <a:xfrm>
               <a:off x="6462712" y="3364706"/>
-              <a:ext cx="4118622" cy="228600"/>
+              <a:ext cx="2757165" cy="173124"/>
             </a:xfrm>
             <a:prstGeom prst="rect">
               <a:avLst/>
@@ -15383,7 +15541,18 @@
                   <a:ea typeface="Microsoft YaHei"/>
                   <a:cs typeface="Aptos"/>
                 </a:rPr>
-                <a:t>P2</a:t>
+                <a:t>P2 </a:t>
+              </a:r>
+              <a:r>
+                <a:rPr lang="en-US" sz="1125" dirty="0" err="1">
+                  <a:solidFill>
+                    <a:srgbClr val="3A4149"/>
+                  </a:solidFill>
+                  <a:latin typeface="Aptos"/>
+                  <a:ea typeface="Microsoft YaHei"/>
+                  <a:cs typeface="Aptos"/>
+                </a:rPr>
+                <a:t>Validazione</a:t>
               </a:r>
               <a:r>
                 <a:rPr lang="en-US" sz="1125" dirty="0">
@@ -15394,7 +15563,7 @@
                   <a:ea typeface="Microsoft YaHei"/>
                   <a:cs typeface="Aptos"/>
                 </a:rPr>
-                <a:t>Validazione deterministica obbligatoria di</a:t>
+                <a:t> deterministica obbligatoria di</a:t>
               </a:r>
             </a:p>
           </p:txBody>
@@ -15448,7 +15617,7 @@
           <p:spPr>
             <a:xfrm>
               <a:off x="6462712" y="4012406"/>
-              <a:ext cx="4533317" cy="228600"/>
+              <a:ext cx="2893421" cy="173124"/>
             </a:xfrm>
             <a:prstGeom prst="rect">
               <a:avLst/>
@@ -15474,7 +15643,7 @@
                   <a:ea typeface="Microsoft YaHei"/>
                   <a:cs typeface="Aptos"/>
                 </a:rPr>
-                <a:t>P3</a:t>
+                <a:t>P3 </a:t>
               </a:r>
               <a:r>
                 <a:rPr lang="en-US" sz="1125" dirty="0">
@@ -15539,7 +15708,7 @@
           <p:spPr>
             <a:xfrm>
               <a:off x="6462712" y="4660106"/>
-              <a:ext cx="4256532" cy="228600"/>
+              <a:ext cx="2872581" cy="173124"/>
             </a:xfrm>
             <a:prstGeom prst="rect">
               <a:avLst/>
@@ -15565,7 +15734,7 @@
                   <a:ea typeface="Microsoft YaHei"/>
                   <a:cs typeface="Aptos"/>
                 </a:rPr>
-                <a:t>P4+P6+P7</a:t>
+                <a:t>P4+P6+P7 </a:t>
               </a:r>
               <a:r>
                 <a:rPr lang="en-US" sz="1125" dirty="0">
@@ -15716,8 +15885,8 @@
         </p:nvSpPr>
         <p:spPr>
           <a:xfrm>
-            <a:off x="725806" y="1008531"/>
-            <a:ext cx="4290297" cy="57600"/>
+            <a:off x="725805" y="1008531"/>
+            <a:ext cx="7128000" cy="57600"/>
           </a:xfrm>
           <a:prstGeom prst="rect">
             <a:avLst/>
@@ -15843,7 +16012,7 @@
         <p:spPr>
           <a:xfrm>
             <a:off x="727710" y="1089660"/>
-            <a:ext cx="8623249" cy="548640"/>
+            <a:ext cx="8490209" cy="415498"/>
           </a:xfrm>
           <a:prstGeom prst="rect">
             <a:avLst/>
@@ -15869,8 +16038,71 @@
                 <a:ea typeface="Microsoft YaHei"/>
                 <a:cs typeface="Segoe UI"/>
               </a:rPr>
-              <a:t>Insecure Inter-Agent Communication</a:t>
+              <a:t>Tampering e Replay </a:t>
             </a:r>
+            <a:r>
+              <a:rPr lang="en-US" sz="2700" b="1" dirty="0" err="1">
+                <a:solidFill>
+                  <a:srgbClr val="1A1D23"/>
+                </a:solidFill>
+                <a:latin typeface="Segoe UI"/>
+                <a:ea typeface="Microsoft YaHei"/>
+                <a:cs typeface="Segoe UI"/>
+              </a:rPr>
+              <a:t>dei</a:t>
+            </a:r>
+            <a:r>
+              <a:rPr lang="en-US" sz="2700" b="1" dirty="0">
+                <a:solidFill>
+                  <a:srgbClr val="1A1D23"/>
+                </a:solidFill>
+                <a:latin typeface="Segoe UI"/>
+                <a:ea typeface="Microsoft YaHei"/>
+                <a:cs typeface="Segoe UI"/>
+              </a:rPr>
+              <a:t> </a:t>
+            </a:r>
+            <a:r>
+              <a:rPr lang="en-US" sz="2700" b="1" dirty="0" err="1">
+                <a:solidFill>
+                  <a:srgbClr val="1A1D23"/>
+                </a:solidFill>
+                <a:latin typeface="Segoe UI"/>
+                <a:ea typeface="Microsoft YaHei"/>
+                <a:cs typeface="Segoe UI"/>
+              </a:rPr>
+              <a:t>Messaggi</a:t>
+            </a:r>
+            <a:r>
+              <a:rPr lang="en-US" sz="2700" b="1" dirty="0">
+                <a:solidFill>
+                  <a:srgbClr val="1A1D23"/>
+                </a:solidFill>
+                <a:latin typeface="Segoe UI"/>
+                <a:ea typeface="Microsoft YaHei"/>
+                <a:cs typeface="Segoe UI"/>
+              </a:rPr>
+              <a:t> di </a:t>
+            </a:r>
+            <a:r>
+              <a:rPr lang="en-US" sz="2700" b="1" dirty="0" err="1">
+                <a:solidFill>
+                  <a:srgbClr val="1A1D23"/>
+                </a:solidFill>
+                <a:latin typeface="Segoe UI"/>
+                <a:ea typeface="Microsoft YaHei"/>
+                <a:cs typeface="Segoe UI"/>
+              </a:rPr>
+              <a:t>Coordinamento</a:t>
+            </a:r>
+            <a:endParaRPr lang="en-US" sz="2700" b="1" dirty="0">
+              <a:solidFill>
+                <a:srgbClr val="1A1D23"/>
+              </a:solidFill>
+              <a:latin typeface="Segoe UI"/>
+              <a:ea typeface="Microsoft YaHei"/>
+              <a:cs typeface="Segoe UI"/>
+            </a:endParaRPr>
           </a:p>
         </p:txBody>
       </p:sp>
@@ -15922,10 +16154,10 @@
         </p:nvGrpSpPr>
         <p:grpSpPr>
           <a:xfrm>
-            <a:off x="1784614" y="1600200"/>
-            <a:ext cx="5793414" cy="264319"/>
-            <a:chOff x="1784614" y="1600200"/>
-            <a:chExt cx="5793414" cy="264319"/>
+            <a:off x="1809750" y="1600200"/>
+            <a:ext cx="5762625" cy="264319"/>
+            <a:chOff x="1809750" y="1600200"/>
+            <a:chExt cx="5762625" cy="264319"/>
           </a:xfrm>
         </p:grpSpPr>
         <p:sp>
@@ -16009,8 +16241,8 @@
           </p:nvSpPr>
           <p:spPr>
             <a:xfrm>
-              <a:off x="1784614" y="1666399"/>
-              <a:ext cx="1288523" cy="198120"/>
+              <a:off x="2000874" y="1666399"/>
+              <a:ext cx="856004" cy="150041"/>
             </a:xfrm>
             <a:prstGeom prst="rect">
               <a:avLst/>
@@ -16028,7 +16260,7 @@
             <a:p>
               <a:pPr algn="ctr"/>
               <a:r>
-                <a:rPr lang="en-US" sz="975" b="1" dirty="0">
+                <a:rPr lang="en-US" sz="975" b="1" dirty="0" err="1">
                   <a:solidFill>
                     <a:srgbClr val="B87710"/>
                   </a:solidFill>
@@ -16036,8 +16268,16 @@
                   <a:ea typeface="Microsoft YaHei"/>
                   <a:cs typeface="Aptos"/>
                 </a:rPr>
-                <a:t>Authentication</a:t>
-              </a:r>
+                <a:t>Autenticazione</a:t>
+              </a:r>
+              <a:endParaRPr lang="en-US" sz="975" b="1" dirty="0">
+                <a:solidFill>
+                  <a:srgbClr val="B87710"/>
+                </a:solidFill>
+                <a:latin typeface="Aptos"/>
+                <a:ea typeface="Microsoft YaHei"/>
+                <a:cs typeface="Aptos"/>
+              </a:endParaRPr>
             </a:p>
           </p:txBody>
         </p:sp>
@@ -16122,8 +16362,8 @@
           </p:nvSpPr>
           <p:spPr>
             <a:xfrm>
-              <a:off x="3168956" y="1666399"/>
-              <a:ext cx="805838" cy="198120"/>
+              <a:off x="3331426" y="1666399"/>
+              <a:ext cx="480901" cy="150041"/>
             </a:xfrm>
             <a:prstGeom prst="rect">
               <a:avLst/>
@@ -16149,7 +16389,7 @@
                   <a:ea typeface="Microsoft YaHei"/>
                   <a:cs typeface="Aptos"/>
                 </a:rPr>
-                <a:t>Integrity</a:t>
+                <a:t>Integrità</a:t>
               </a:r>
             </a:p>
           </p:txBody>
@@ -16348,8 +16588,8 @@
           </p:nvSpPr>
           <p:spPr>
             <a:xfrm>
-              <a:off x="5304475" y="1666399"/>
-              <a:ext cx="1297299" cy="198120"/>
+              <a:off x="5519514" y="1666399"/>
+              <a:ext cx="867225" cy="150041"/>
             </a:xfrm>
             <a:prstGeom prst="rect">
               <a:avLst/>
@@ -16367,7 +16607,7 @@
             <a:p>
               <a:pPr algn="ctr"/>
               <a:r>
-                <a:rPr lang="en-US" sz="975" b="1" dirty="0">
+                <a:rPr lang="en-US" sz="975" b="1" dirty="0" err="1">
                   <a:solidFill>
                     <a:srgbClr val="B87710"/>
                   </a:solidFill>
@@ -16375,8 +16615,16 @@
                   <a:ea typeface="Microsoft YaHei"/>
                   <a:cs typeface="Aptos"/>
                 </a:rPr>
-                <a:t>Confidentiality</a:t>
-              </a:r>
+                <a:t>Confidenzialità</a:t>
+              </a:r>
+              <a:endParaRPr lang="en-US" sz="975" b="1" dirty="0">
+                <a:solidFill>
+                  <a:srgbClr val="B87710"/>
+                </a:solidFill>
+                <a:latin typeface="Aptos"/>
+                <a:ea typeface="Microsoft YaHei"/>
+                <a:cs typeface="Aptos"/>
+              </a:endParaRPr>
             </a:p>
           </p:txBody>
         </p:sp>
@@ -16461,8 +16709,8 @@
           </p:nvSpPr>
           <p:spPr>
             <a:xfrm>
-              <a:off x="6614221" y="1666399"/>
-              <a:ext cx="963807" cy="198120"/>
+              <a:off x="6731442" y="1666399"/>
+              <a:ext cx="729367" cy="150041"/>
             </a:xfrm>
             <a:prstGeom prst="rect">
               <a:avLst/>
@@ -16488,7 +16736,7 @@
                   <a:ea typeface="Microsoft YaHei"/>
                   <a:cs typeface="Aptos"/>
                 </a:rPr>
-                <a:t>Availability</a:t>
+                <a:t>Disponibilità</a:t>
               </a:r>
             </a:p>
           </p:txBody>
@@ -17082,7 +17330,7 @@
           <p:spPr>
             <a:xfrm>
               <a:off x="6462712" y="2717006"/>
-              <a:ext cx="3964317" cy="228600"/>
+              <a:ext cx="2601674" cy="173124"/>
             </a:xfrm>
             <a:prstGeom prst="rect">
               <a:avLst/>
@@ -17108,7 +17356,7 @@
                   <a:ea typeface="Microsoft YaHei"/>
                   <a:cs typeface="Aptos"/>
                 </a:rPr>
-                <a:t>P1</a:t>
+                <a:t>P1 </a:t>
               </a:r>
               <a:r>
                 <a:rPr lang="en-US" sz="1125" dirty="0">
@@ -17173,7 +17421,7 @@
           <p:spPr>
             <a:xfrm>
               <a:off x="6462712" y="3364706"/>
-              <a:ext cx="3829300" cy="228600"/>
+              <a:ext cx="2537554" cy="173124"/>
             </a:xfrm>
             <a:prstGeom prst="rect">
               <a:avLst/>
@@ -17199,7 +17447,18 @@
                   <a:ea typeface="Microsoft YaHei"/>
                   <a:cs typeface="Aptos"/>
                 </a:rPr>
-                <a:t>P2</a:t>
+                <a:t>P2 </a:t>
+              </a:r>
+              <a:r>
+                <a:rPr lang="en-US" sz="1125" dirty="0" err="1">
+                  <a:solidFill>
+                    <a:srgbClr val="3A4149"/>
+                  </a:solidFill>
+                  <a:latin typeface="Aptos"/>
+                  <a:ea typeface="Microsoft YaHei"/>
+                  <a:cs typeface="Aptos"/>
+                </a:rPr>
+                <a:t>Validazione</a:t>
               </a:r>
               <a:r>
                 <a:rPr lang="en-US" sz="1125" dirty="0">
@@ -17210,7 +17469,7 @@
                   <a:ea typeface="Microsoft YaHei"/>
                   <a:cs typeface="Aptos"/>
                 </a:rPr>
-                <a:t>Validazione (M11) di macchina a stati,</a:t>
+                <a:t> (M11) di macchina a stati,</a:t>
               </a:r>
             </a:p>
           </p:txBody>
@@ -17304,7 +17563,7 @@
           <p:spPr>
             <a:xfrm>
               <a:off x="6462712" y="4260056"/>
-              <a:ext cx="4118622" cy="228600"/>
+              <a:ext cx="2782813" cy="173124"/>
             </a:xfrm>
             <a:prstGeom prst="rect">
               <a:avLst/>
@@ -17330,7 +17589,7 @@
                   <a:ea typeface="Microsoft YaHei"/>
                   <a:cs typeface="Aptos"/>
                 </a:rPr>
-                <a:t>P3</a:t>
+                <a:t>P3 </a:t>
               </a:r>
               <a:r>
                 <a:rPr lang="en-US" sz="1125" dirty="0">
@@ -17395,7 +17654,7 @@
           <p:spPr>
             <a:xfrm>
               <a:off x="6462712" y="4907756"/>
-              <a:ext cx="4584430" cy="228600"/>
+              <a:ext cx="2973571" cy="173124"/>
             </a:xfrm>
             <a:prstGeom prst="rect">
               <a:avLst/>
@@ -17421,7 +17680,7 @@
                   <a:ea typeface="Microsoft YaHei"/>
                   <a:cs typeface="Aptos"/>
                 </a:rPr>
-                <a:t>P4+P6+P7</a:t>
+                <a:t>P4+P6+P7 </a:t>
               </a:r>
               <a:r>
                 <a:rPr lang="en-US" sz="1125" dirty="0">
@@ -17532,8 +17791,8 @@
         </p:nvSpPr>
         <p:spPr>
           <a:xfrm>
-            <a:off x="725806" y="1008531"/>
-            <a:ext cx="6009291" cy="57600"/>
+            <a:off x="725805" y="1008531"/>
+            <a:ext cx="8388000" cy="57600"/>
           </a:xfrm>
           <a:prstGeom prst="rect">
             <a:avLst/>
@@ -17589,7 +17848,7 @@
         </p:nvSpPr>
         <p:spPr>
           <a:xfrm>
-            <a:off x="0" y="0"/>
+            <a:off x="0" y="9832"/>
             <a:ext cx="12192000" cy="6858000"/>
           </a:xfrm>
           <a:prstGeom prst="rect">
@@ -17659,7 +17918,7 @@
         <p:spPr>
           <a:xfrm>
             <a:off x="727710" y="1089660"/>
-            <a:ext cx="7578219" cy="548640"/>
+            <a:ext cx="7375096" cy="415498"/>
           </a:xfrm>
           <a:prstGeom prst="rect">
             <a:avLst/>
@@ -17677,6 +17936,17 @@
           <a:p>
             <a:pPr algn="l"/>
             <a:r>
+              <a:rPr lang="en-US" sz="2700" b="1" dirty="0" err="1">
+                <a:solidFill>
+                  <a:srgbClr val="1A1D23"/>
+                </a:solidFill>
+                <a:latin typeface="Segoe UI"/>
+                <a:ea typeface="Microsoft YaHei"/>
+                <a:cs typeface="Segoe UI"/>
+              </a:rPr>
+              <a:t>Sfruttamento</a:t>
+            </a:r>
+            <a:r>
               <a:rPr lang="en-US" sz="2700" b="1" dirty="0">
                 <a:solidFill>
                   <a:srgbClr val="1A1D23"/>
@@ -17685,7 +17955,29 @@
                 <a:ea typeface="Microsoft YaHei"/>
                 <a:cs typeface="Segoe UI"/>
               </a:rPr>
-              <a:t>Human-Agent Trust Exploitation</a:t>
+              <a:t> della Fiducia </a:t>
+            </a:r>
+            <a:r>
+              <a:rPr lang="en-US" sz="2700" b="1" dirty="0" err="1">
+                <a:solidFill>
+                  <a:srgbClr val="1A1D23"/>
+                </a:solidFill>
+                <a:latin typeface="Segoe UI"/>
+                <a:ea typeface="Microsoft YaHei"/>
+                <a:cs typeface="Segoe UI"/>
+              </a:rPr>
+              <a:t>nel</a:t>
+            </a:r>
+            <a:r>
+              <a:rPr lang="en-US" sz="2700" b="1" dirty="0">
+                <a:solidFill>
+                  <a:srgbClr val="1A1D23"/>
+                </a:solidFill>
+                <a:latin typeface="Segoe UI"/>
+                <a:ea typeface="Microsoft YaHei"/>
+                <a:cs typeface="Segoe UI"/>
+              </a:rPr>
+              <a:t> Digital Human</a:t>
             </a:r>
           </a:p>
         </p:txBody>
@@ -17825,8 +18117,8 @@
           </p:nvSpPr>
           <p:spPr>
             <a:xfrm>
-              <a:off x="1835456" y="1666399"/>
-              <a:ext cx="805838" cy="198120"/>
+              <a:off x="1997926" y="1666399"/>
+              <a:ext cx="480901" cy="150041"/>
             </a:xfrm>
             <a:prstGeom prst="rect">
               <a:avLst/>
@@ -17852,7 +18144,7 @@
                   <a:ea typeface="Microsoft YaHei"/>
                   <a:cs typeface="Aptos"/>
                 </a:rPr>
-                <a:t>Integrity</a:t>
+                <a:t>Integrità</a:t>
               </a:r>
             </a:p>
           </p:txBody>
@@ -17938,8 +18230,8 @@
           </p:nvSpPr>
           <p:spPr>
             <a:xfrm>
-              <a:off x="2685100" y="1666399"/>
-              <a:ext cx="1297299" cy="198120"/>
+              <a:off x="2900139" y="1666399"/>
+              <a:ext cx="867225" cy="150041"/>
             </a:xfrm>
             <a:prstGeom prst="rect">
               <a:avLst/>
@@ -17957,7 +18249,7 @@
             <a:p>
               <a:pPr algn="ctr"/>
               <a:r>
-                <a:rPr lang="en-US" sz="975" b="1" dirty="0">
+                <a:rPr lang="en-US" sz="975" b="1" dirty="0" err="1">
                   <a:solidFill>
                     <a:srgbClr val="B87710"/>
                   </a:solidFill>
@@ -17965,8 +18257,16 @@
                   <a:ea typeface="Microsoft YaHei"/>
                   <a:cs typeface="Aptos"/>
                 </a:rPr>
-                <a:t>Confidentiality</a:t>
-              </a:r>
+                <a:t>Confidenzialità</a:t>
+              </a:r>
+              <a:endParaRPr lang="en-US" sz="975" b="1" dirty="0">
+                <a:solidFill>
+                  <a:srgbClr val="B87710"/>
+                </a:solidFill>
+                <a:latin typeface="Aptos"/>
+                <a:ea typeface="Microsoft YaHei"/>
+                <a:cs typeface="Aptos"/>
+              </a:endParaRPr>
             </a:p>
           </p:txBody>
         </p:sp>
@@ -18051,8 +18351,8 @@
           </p:nvSpPr>
           <p:spPr>
             <a:xfrm>
-              <a:off x="3975364" y="1666399"/>
-              <a:ext cx="1288523" cy="198120"/>
+              <a:off x="4191625" y="1666399"/>
+              <a:ext cx="856005" cy="150041"/>
             </a:xfrm>
             <a:prstGeom prst="rect">
               <a:avLst/>
@@ -18070,7 +18370,7 @@
             <a:p>
               <a:pPr algn="ctr"/>
               <a:r>
-                <a:rPr lang="en-US" sz="975" b="1" dirty="0">
+                <a:rPr lang="en-US" sz="975" b="1" dirty="0" err="1">
                   <a:solidFill>
                     <a:srgbClr val="B87710"/>
                   </a:solidFill>
@@ -18078,8 +18378,16 @@
                   <a:ea typeface="Microsoft YaHei"/>
                   <a:cs typeface="Aptos"/>
                 </a:rPr>
-                <a:t>Authentication</a:t>
-              </a:r>
+                <a:t>Autenticazione</a:t>
+              </a:r>
+              <a:endParaRPr lang="en-US" sz="975" b="1" dirty="0">
+                <a:solidFill>
+                  <a:srgbClr val="B87710"/>
+                </a:solidFill>
+                <a:latin typeface="Aptos"/>
+                <a:ea typeface="Microsoft YaHei"/>
+                <a:cs typeface="Aptos"/>
+              </a:endParaRPr>
             </a:p>
           </p:txBody>
         </p:sp>
@@ -18825,7 +19133,7 @@
           <p:spPr>
             <a:xfrm>
               <a:off x="6462712" y="2717006"/>
-              <a:ext cx="4340435" cy="228600"/>
+              <a:ext cx="2882199" cy="173124"/>
             </a:xfrm>
             <a:prstGeom prst="rect">
               <a:avLst/>
@@ -18851,7 +19159,18 @@
                   <a:ea typeface="Microsoft YaHei"/>
                   <a:cs typeface="Aptos"/>
                 </a:rPr>
-                <a:t>P1</a:t>
+                <a:t>P1 </a:t>
+              </a:r>
+              <a:r>
+                <a:rPr lang="en-US" sz="1125" dirty="0" err="1">
+                  <a:solidFill>
+                    <a:srgbClr val="3A4149"/>
+                  </a:solidFill>
+                  <a:latin typeface="Aptos"/>
+                  <a:ea typeface="Microsoft YaHei"/>
+                  <a:cs typeface="Aptos"/>
+                </a:rPr>
+                <a:t>Divieto</a:t>
               </a:r>
               <a:r>
                 <a:rPr lang="en-US" sz="1125" dirty="0">
@@ -18862,7 +19181,7 @@
                   <a:ea typeface="Microsoft YaHei"/>
                   <a:cs typeface="Aptos"/>
                 </a:rPr>
-                <a:t>Divieto di richiedere dati personali; dominio</a:t>
+                <a:t> di richiedere dati personali; dominio</a:t>
               </a:r>
             </a:p>
           </p:txBody>
@@ -18916,7 +19235,7 @@
           <p:spPr>
             <a:xfrm>
               <a:off x="6462712" y="3364706"/>
-              <a:ext cx="4350079" cy="228600"/>
+              <a:ext cx="2895023" cy="173124"/>
             </a:xfrm>
             <a:prstGeom prst="rect">
               <a:avLst/>
@@ -18942,7 +19261,7 @@
                   <a:ea typeface="Microsoft YaHei"/>
                   <a:cs typeface="Aptos"/>
                 </a:rPr>
-                <a:t>P2</a:t>
+                <a:t>P2 </a:t>
               </a:r>
               <a:r>
                 <a:rPr lang="en-US" sz="1125" dirty="0">
@@ -19007,7 +19326,7 @@
           <p:spPr>
             <a:xfrm>
               <a:off x="6462712" y="4012406"/>
-              <a:ext cx="4436876" cy="228600"/>
+              <a:ext cx="2903039" cy="173124"/>
             </a:xfrm>
             <a:prstGeom prst="rect">
               <a:avLst/>
@@ -19033,7 +19352,7 @@
                   <a:ea typeface="Microsoft YaHei"/>
                   <a:cs typeface="Aptos"/>
                 </a:rPr>
-                <a:t>P3</a:t>
+                <a:t>P3 </a:t>
               </a:r>
               <a:r>
                 <a:rPr lang="en-US" sz="1125" dirty="0">
@@ -19098,7 +19417,7 @@
           <p:spPr>
             <a:xfrm>
               <a:off x="6462712" y="4660106"/>
-              <a:ext cx="4497634" cy="228600"/>
+              <a:ext cx="3039294" cy="173124"/>
             </a:xfrm>
             <a:prstGeom prst="rect">
               <a:avLst/>
@@ -19124,7 +19443,7 @@
                   <a:ea typeface="Microsoft YaHei"/>
                   <a:cs typeface="Aptos"/>
                 </a:rPr>
-                <a:t>P4+P6+P7</a:t>
+                <a:t>P4+P6+P7 </a:t>
               </a:r>
               <a:r>
                 <a:rPr lang="en-US" sz="1125" dirty="0">
@@ -19275,8 +19594,8 @@
         </p:nvSpPr>
         <p:spPr>
           <a:xfrm>
-            <a:off x="725806" y="1008531"/>
-            <a:ext cx="5252207" cy="57600"/>
+            <a:off x="725805" y="1008531"/>
+            <a:ext cx="7272000" cy="57600"/>
           </a:xfrm>
           <a:prstGeom prst="rect">
             <a:avLst/>

</xml_diff>